<commit_message>
add papers for lecture 4
</commit_message>
<xml_diff>
--- a/papers/lektion-4.pptx
+++ b/papers/lektion-4.pptx
@@ -5,10 +5,10 @@
     <p:sldMasterId id="2147483648" r:id="rId4"/>
   </p:sldMasterIdLst>
   <p:notesMasterIdLst>
-    <p:notesMasterId r:id="rId18"/>
+    <p:notesMasterId r:id="rId19"/>
   </p:notesMasterIdLst>
   <p:handoutMasterIdLst>
-    <p:handoutMasterId r:id="rId19"/>
+    <p:handoutMasterId r:id="rId20"/>
   </p:handoutMasterIdLst>
   <p:sldIdLst>
     <p:sldId id="256" r:id="rId5"/>
@@ -21,9 +21,10 @@
     <p:sldId id="317" r:id="rId12"/>
     <p:sldId id="319" r:id="rId13"/>
     <p:sldId id="318" r:id="rId14"/>
-    <p:sldId id="295" r:id="rId15"/>
-    <p:sldId id="298" r:id="rId16"/>
-    <p:sldId id="272" r:id="rId17"/>
+    <p:sldId id="320" r:id="rId15"/>
+    <p:sldId id="295" r:id="rId16"/>
+    <p:sldId id="298" r:id="rId17"/>
+    <p:sldId id="272" r:id="rId18"/>
   </p:sldIdLst>
   <p:sldSz cx="12192000" cy="6858000"/>
   <p:notesSz cx="6797675" cy="9926638"/>
@@ -145,6 +146,7 @@
             <p14:sldId id="317"/>
             <p14:sldId id="319"/>
             <p14:sldId id="318"/>
+            <p14:sldId id="320"/>
           </p14:sldIdLst>
         </p14:section>
         <p14:section name="Abschluss" id="{BDD9CAB4-1E85-4AAD-9582-8A028B42FA47}">
@@ -248,7 +250,7 @@
           <a:p>
             <a:fld id="{FC23D672-218E-44CF-A13C-71AB61B14F4F}" type="datetimeFigureOut">
               <a:rPr lang="de-CH" smtClean="0"/>
-              <a:t>09.02.2025</a:t>
+              <a:t>10.02.2025</a:t>
             </a:fld>
             <a:endParaRPr lang="de-CH"/>
           </a:p>
@@ -413,7 +415,7 @@
           <a:p>
             <a:fld id="{93FA598B-8DA1-4BBA-9EA9-DC1615E9868A}" type="datetimeFigureOut">
               <a:rPr lang="de-CH" smtClean="0"/>
-              <a:t>09.02.2025</a:t>
+              <a:t>10.02.2025</a:t>
             </a:fld>
             <a:endParaRPr lang="de-CH"/>
           </a:p>
@@ -1006,7 +1008,7 @@
           <a:p>
             <a:fld id="{9B3C940E-24E7-4D1A-B11D-DBBBB544974E}" type="slidenum">
               <a:rPr lang="de-CH" smtClean="0"/>
-              <a:t>11</a:t>
+              <a:t>12</a:t>
             </a:fld>
             <a:endParaRPr lang="de-CH"/>
           </a:p>
@@ -1094,7 +1096,7 @@
           <a:p>
             <a:fld id="{9B3C940E-24E7-4D1A-B11D-DBBBB544974E}" type="slidenum">
               <a:rPr lang="de-CH" smtClean="0"/>
-              <a:t>12</a:t>
+              <a:t>13</a:t>
             </a:fld>
             <a:endParaRPr lang="de-CH"/>
           </a:p>
@@ -1182,7 +1184,7 @@
           <a:p>
             <a:fld id="{9B3C940E-24E7-4D1A-B11D-DBBBB544974E}" type="slidenum">
               <a:rPr lang="de-CH" smtClean="0"/>
-              <a:t>13</a:t>
+              <a:t>14</a:t>
             </a:fld>
             <a:endParaRPr lang="de-CH"/>
           </a:p>
@@ -1403,7 +1405,7 @@
           <a:p>
             <a:fld id="{6853F526-C1D0-4550-B781-F5C2F41E5AD9}" type="datetime1">
               <a:rPr lang="de-CH" smtClean="0"/>
-              <a:t>09.02.2025</a:t>
+              <a:t>10.02.2025</a:t>
             </a:fld>
             <a:endParaRPr lang="de-CH"/>
           </a:p>
@@ -1539,7 +1541,7 @@
           <a:p>
             <a:fld id="{A1523D7E-84BA-4532-8AC0-0461707F3C45}" type="datetime1">
               <a:rPr lang="de-CH" smtClean="0"/>
-              <a:t>09.02.2025</a:t>
+              <a:t>10.02.2025</a:t>
             </a:fld>
             <a:endParaRPr lang="de-CH"/>
           </a:p>
@@ -1697,7 +1699,7 @@
           <a:p>
             <a:fld id="{A1523D7E-84BA-4532-8AC0-0461707F3C45}" type="datetime1">
               <a:rPr lang="de-CH" smtClean="0"/>
-              <a:t>09.02.2025</a:t>
+              <a:t>10.02.2025</a:t>
             </a:fld>
             <a:endParaRPr lang="de-CH"/>
           </a:p>
@@ -2325,7 +2327,7 @@
           <a:p>
             <a:fld id="{107B2E98-33F3-4843-92CD-A9A795F13784}" type="datetime1">
               <a:rPr lang="de-CH" smtClean="0"/>
-              <a:t>09.02.2025</a:t>
+              <a:t>10.02.2025</a:t>
             </a:fld>
             <a:endParaRPr lang="de-CH"/>
           </a:p>
@@ -2454,7 +2456,7 @@
           <a:p>
             <a:fld id="{A1523D7E-84BA-4532-8AC0-0461707F3C45}" type="datetime1">
               <a:rPr lang="de-CH" smtClean="0"/>
-              <a:t>09.02.2025</a:t>
+              <a:t>10.02.2025</a:t>
             </a:fld>
             <a:endParaRPr lang="de-CH"/>
           </a:p>
@@ -3096,7 +3098,7 @@
           <a:p>
             <a:fld id="{6853F526-C1D0-4550-B781-F5C2F41E5AD9}" type="datetime1">
               <a:rPr lang="de-CH" smtClean="0"/>
-              <a:t>09.02.2025</a:t>
+              <a:t>10.02.2025</a:t>
             </a:fld>
             <a:endParaRPr lang="de-CH"/>
           </a:p>
@@ -3232,7 +3234,7 @@
           <a:p>
             <a:fld id="{A1523D7E-84BA-4532-8AC0-0461707F3C45}" type="datetime1">
               <a:rPr lang="de-CH" smtClean="0"/>
-              <a:t>09.02.2025</a:t>
+              <a:t>10.02.2025</a:t>
             </a:fld>
             <a:endParaRPr lang="de-CH"/>
           </a:p>
@@ -3475,7 +3477,7 @@
           <a:p>
             <a:fld id="{A1523D7E-84BA-4532-8AC0-0461707F3C45}" type="datetime1">
               <a:rPr lang="de-CH" smtClean="0"/>
-              <a:t>09.02.2025</a:t>
+              <a:t>10.02.2025</a:t>
             </a:fld>
             <a:endParaRPr lang="de-CH"/>
           </a:p>
@@ -3791,7 +3793,7 @@
           <a:p>
             <a:fld id="{A1523D7E-84BA-4532-8AC0-0461707F3C45}" type="datetime1">
               <a:rPr lang="de-CH" smtClean="0"/>
-              <a:t>09.02.2025</a:t>
+              <a:t>10.02.2025</a:t>
             </a:fld>
             <a:endParaRPr lang="de-CH"/>
           </a:p>
@@ -4155,7 +4157,7 @@
           <a:p>
             <a:fld id="{0F06BCF4-0E81-4303-B76F-6C3D6B7E70BE}" type="datetime1">
               <a:rPr lang="de-CH" smtClean="0"/>
-              <a:t>09.02.2025</a:t>
+              <a:t>10.02.2025</a:t>
             </a:fld>
             <a:endParaRPr lang="de-CH"/>
           </a:p>
@@ -4279,7 +4281,7 @@
           <a:p>
             <a:fld id="{A1523D7E-84BA-4532-8AC0-0461707F3C45}" type="datetime1">
               <a:rPr lang="de-CH" smtClean="0"/>
-              <a:t>09.02.2025</a:t>
+              <a:t>10.02.2025</a:t>
             </a:fld>
             <a:endParaRPr lang="de-CH"/>
           </a:p>
@@ -4525,7 +4527,7 @@
             <a:fld id="{A1523D7E-84BA-4532-8AC0-0461707F3C45}" type="datetime1">
               <a:rPr lang="de-CH" smtClean="0"/>
               <a:pPr/>
-              <a:t>09.02.2025</a:t>
+              <a:t>10.02.2025</a:t>
             </a:fld>
             <a:endParaRPr lang="de-CH" dirty="0"/>
           </a:p>
@@ -5210,44 +5212,10 @@
             </a:r>
           </a:p>
           <a:p>
+            <a:pPr marL="0" indent="0">
+              <a:buNone/>
+            </a:pPr>
             <a:endParaRPr lang="de-CH" dirty="0"/>
-          </a:p>
-          <a:p>
-            <a:r>
-              <a:rPr lang="de-CH" dirty="0"/>
-              <a:t>Was für ein Mini-Web-Projekt möchtet ihr in der verbleibenden Zeit machen?</a:t>
-            </a:r>
-          </a:p>
-          <a:p>
-            <a:pPr lvl="1"/>
-            <a:r>
-              <a:rPr lang="de-CH" dirty="0"/>
-              <a:t>Schreibt ein Konzept, skizziert eure Idee</a:t>
-            </a:r>
-          </a:p>
-          <a:p>
-            <a:pPr lvl="1"/>
-            <a:r>
-              <a:rPr lang="de-CH" dirty="0"/>
-              <a:t>Besprechung mit mir und dann </a:t>
-            </a:r>
-            <a:r>
-              <a:rPr lang="de-CH" dirty="0" err="1"/>
-              <a:t>let’s</a:t>
-            </a:r>
-            <a:r>
-              <a:rPr lang="de-CH" dirty="0"/>
-              <a:t> </a:t>
-            </a:r>
-            <a:r>
-              <a:rPr lang="de-CH" dirty="0" err="1"/>
-              <a:t>go</a:t>
-            </a:r>
-            <a:r>
-              <a:rPr lang="de-CH" dirty="0"/>
-              <a:t>!</a:t>
-            </a:r>
-            <a:endParaRPr lang="LID4096" dirty="0"/>
           </a:p>
         </p:txBody>
       </p:sp>
@@ -5265,11 +5233,17 @@
 </file>
 
 <file path=ppt/slides/slide11.xml><?xml version="1.0" encoding="utf-8"?>
-<p:sld xmlns:a="http://schemas.openxmlformats.org/drawingml/2006/main" xmlns:r="http://schemas.openxmlformats.org/officeDocument/2006/relationships" xmlns:p="http://schemas.openxmlformats.org/presentationml/2006/main">
+<p:sld xmlns:a="http://schemas.openxmlformats.org/drawingml/2006/main" xmlns:r="http://schemas.openxmlformats.org/officeDocument/2006/relationships" xmlns:p="http://schemas.openxmlformats.org/presentationml/2006/main" show="0">
   <p:cSld>
     <p:spTree>
       <p:nvGrpSpPr>
-        <p:cNvPr id="1" name=""/>
+        <p:cNvPr id="1" name="">
+          <a:extLst>
+            <a:ext uri="{FF2B5EF4-FFF2-40B4-BE49-F238E27FC236}">
+              <a16:creationId xmlns:a16="http://schemas.microsoft.com/office/drawing/2014/main" id="{6DCE6916-E3C4-FC52-2916-F0D2D231EB85}"/>
+            </a:ext>
+          </a:extLst>
+        </p:cNvPr>
         <p:cNvGrpSpPr/>
         <p:nvPr/>
       </p:nvGrpSpPr>
@@ -5286,7 +5260,7 @@
           <p:cNvPr id="2" name="Titel 1">
             <a:extLst>
               <a:ext uri="{FF2B5EF4-FFF2-40B4-BE49-F238E27FC236}">
-                <a16:creationId xmlns:a16="http://schemas.microsoft.com/office/drawing/2014/main" id="{24454B8E-2325-A7D7-2AC9-6809A90974AC}"/>
+                <a16:creationId xmlns:a16="http://schemas.microsoft.com/office/drawing/2014/main" id="{B13B6487-AFA0-D4F8-034F-C9AD1D459E1A}"/>
               </a:ext>
             </a:extLst>
           </p:cNvPr>
@@ -5304,7 +5278,7 @@
           <a:p>
             <a:r>
               <a:rPr lang="de-CH" dirty="0"/>
-              <a:t>Ausblick</a:t>
+              <a:t>Überlegt euch</a:t>
             </a:r>
             <a:endParaRPr lang="LID4096" dirty="0"/>
           </a:p>
@@ -5315,7 +5289,7 @@
           <p:cNvPr id="3" name="Foliennummernplatzhalter 2">
             <a:extLst>
               <a:ext uri="{FF2B5EF4-FFF2-40B4-BE49-F238E27FC236}">
-                <a16:creationId xmlns:a16="http://schemas.microsoft.com/office/drawing/2014/main" id="{60E9A9BC-671F-045C-2E69-81D87F03A5F4}"/>
+                <a16:creationId xmlns:a16="http://schemas.microsoft.com/office/drawing/2014/main" id="{13416C37-8150-571F-1412-10E6160900F9}"/>
               </a:ext>
             </a:extLst>
           </p:cNvPr>
@@ -5345,7 +5319,7 @@
           <p:cNvPr id="4" name="Inhaltsplatzhalter 3">
             <a:extLst>
               <a:ext uri="{FF2B5EF4-FFF2-40B4-BE49-F238E27FC236}">
-                <a16:creationId xmlns:a16="http://schemas.microsoft.com/office/drawing/2014/main" id="{B773142B-56F2-E851-90A7-FA21492D8766}"/>
+                <a16:creationId xmlns:a16="http://schemas.microsoft.com/office/drawing/2014/main" id="{DE3EB336-1E0E-E934-A551-A8F14B62C193}"/>
               </a:ext>
             </a:extLst>
           </p:cNvPr>
@@ -5363,15 +5337,55 @@
           <a:p>
             <a:r>
               <a:rPr lang="de-CH" dirty="0"/>
-              <a:t>Individuelle Erweiterung</a:t>
-            </a:r>
+              <a:t>Gibt es ein Thema in JavaScript, welches ihr noch gerne gemeinsam anschauen möchtet?</a:t>
+            </a:r>
+          </a:p>
+          <a:p>
+            <a:endParaRPr lang="de-CH" dirty="0"/>
+          </a:p>
+          <a:p>
+            <a:r>
+              <a:rPr lang="de-CH" dirty="0"/>
+              <a:t>Was für ein Mini-Web-Projekt möchtet ihr in der verbleibenden Zeit machen?</a:t>
+            </a:r>
+          </a:p>
+          <a:p>
+            <a:pPr lvl="1"/>
+            <a:r>
+              <a:rPr lang="de-CH" dirty="0"/>
+              <a:t>Schreibt ein Konzept, skizziert eure Idee</a:t>
+            </a:r>
+          </a:p>
+          <a:p>
+            <a:pPr lvl="1"/>
+            <a:r>
+              <a:rPr lang="de-CH" dirty="0"/>
+              <a:t>Besprechung mit mir und dann </a:t>
+            </a:r>
+            <a:r>
+              <a:rPr lang="de-CH" dirty="0" err="1"/>
+              <a:t>let’s</a:t>
+            </a:r>
+            <a:r>
+              <a:rPr lang="de-CH" dirty="0"/>
+              <a:t> </a:t>
+            </a:r>
+            <a:r>
+              <a:rPr lang="de-CH" dirty="0" err="1"/>
+              <a:t>go</a:t>
+            </a:r>
+            <a:r>
+              <a:rPr lang="de-CH" dirty="0"/>
+              <a:t>!</a:t>
+            </a:r>
+            <a:endParaRPr lang="LID4096" dirty="0"/>
           </a:p>
         </p:txBody>
       </p:sp>
     </p:spTree>
     <p:extLst>
       <p:ext uri="{BB962C8B-B14F-4D97-AF65-F5344CB8AC3E}">
-        <p14:creationId xmlns:p14="http://schemas.microsoft.com/office/powerpoint/2010/main" val="1936636184"/>
+        <p14:creationId xmlns:p14="http://schemas.microsoft.com/office/powerpoint/2010/main" val="1363735139"/>
       </p:ext>
     </p:extLst>
   </p:cSld>
@@ -5421,7 +5435,7 @@
           <a:p>
             <a:r>
               <a:rPr lang="de-CH" dirty="0"/>
-              <a:t>Aufräumen</a:t>
+              <a:t>Ausblick</a:t>
             </a:r>
             <a:endParaRPr lang="LID4096" dirty="0"/>
           </a:p>
@@ -5478,14 +5492,17 @@
           <a:bodyPr/>
           <a:lstStyle/>
           <a:p>
-            <a:endParaRPr lang="LID4096" dirty="0"/>
+            <a:r>
+              <a:rPr lang="de-CH" dirty="0"/>
+              <a:t>Follow-Up ML5</a:t>
+            </a:r>
           </a:p>
         </p:txBody>
       </p:sp>
     </p:spTree>
     <p:extLst>
       <p:ext uri="{BB962C8B-B14F-4D97-AF65-F5344CB8AC3E}">
-        <p14:creationId xmlns:p14="http://schemas.microsoft.com/office/powerpoint/2010/main" val="2340779447"/>
+        <p14:creationId xmlns:p14="http://schemas.microsoft.com/office/powerpoint/2010/main" val="1936636184"/>
       </p:ext>
     </p:extLst>
   </p:cSld>
@@ -5517,6 +5534,120 @@
           <p:cNvPr id="2" name="Titel 1">
             <a:extLst>
               <a:ext uri="{FF2B5EF4-FFF2-40B4-BE49-F238E27FC236}">
+                <a16:creationId xmlns:a16="http://schemas.microsoft.com/office/drawing/2014/main" id="{24454B8E-2325-A7D7-2AC9-6809A90974AC}"/>
+              </a:ext>
+            </a:extLst>
+          </p:cNvPr>
+          <p:cNvSpPr>
+            <a:spLocks noGrp="1"/>
+          </p:cNvSpPr>
+          <p:nvPr>
+            <p:ph type="title"/>
+          </p:nvPr>
+        </p:nvSpPr>
+        <p:spPr/>
+        <p:txBody>
+          <a:bodyPr/>
+          <a:lstStyle/>
+          <a:p>
+            <a:r>
+              <a:rPr lang="de-CH" dirty="0"/>
+              <a:t>Aufräumen</a:t>
+            </a:r>
+            <a:endParaRPr lang="LID4096" dirty="0"/>
+          </a:p>
+        </p:txBody>
+      </p:sp>
+      <p:sp>
+        <p:nvSpPr>
+          <p:cNvPr id="3" name="Foliennummernplatzhalter 2">
+            <a:extLst>
+              <a:ext uri="{FF2B5EF4-FFF2-40B4-BE49-F238E27FC236}">
+                <a16:creationId xmlns:a16="http://schemas.microsoft.com/office/drawing/2014/main" id="{60E9A9BC-671F-045C-2E69-81D87F03A5F4}"/>
+              </a:ext>
+            </a:extLst>
+          </p:cNvPr>
+          <p:cNvSpPr>
+            <a:spLocks noGrp="1"/>
+          </p:cNvSpPr>
+          <p:nvPr>
+            <p:ph type="sldNum" sz="quarter" idx="12"/>
+          </p:nvPr>
+        </p:nvSpPr>
+        <p:spPr/>
+        <p:txBody>
+          <a:bodyPr/>
+          <a:lstStyle/>
+          <a:p>
+            <a:fld id="{7759694E-24C5-490B-A8F1-97FE52F5A3A6}" type="slidenum">
+              <a:rPr lang="de-CH" smtClean="0"/>
+              <a:pPr/>
+              <a:t>13</a:t>
+            </a:fld>
+            <a:endParaRPr lang="de-CH" dirty="0"/>
+          </a:p>
+        </p:txBody>
+      </p:sp>
+      <p:sp>
+        <p:nvSpPr>
+          <p:cNvPr id="4" name="Inhaltsplatzhalter 3">
+            <a:extLst>
+              <a:ext uri="{FF2B5EF4-FFF2-40B4-BE49-F238E27FC236}">
+                <a16:creationId xmlns:a16="http://schemas.microsoft.com/office/drawing/2014/main" id="{B773142B-56F2-E851-90A7-FA21492D8766}"/>
+              </a:ext>
+            </a:extLst>
+          </p:cNvPr>
+          <p:cNvSpPr>
+            <a:spLocks noGrp="1"/>
+          </p:cNvSpPr>
+          <p:nvPr>
+            <p:ph idx="1"/>
+          </p:nvPr>
+        </p:nvSpPr>
+        <p:spPr/>
+        <p:txBody>
+          <a:bodyPr/>
+          <a:lstStyle/>
+          <a:p>
+            <a:endParaRPr lang="LID4096" dirty="0"/>
+          </a:p>
+        </p:txBody>
+      </p:sp>
+    </p:spTree>
+    <p:extLst>
+      <p:ext uri="{BB962C8B-B14F-4D97-AF65-F5344CB8AC3E}">
+        <p14:creationId xmlns:p14="http://schemas.microsoft.com/office/powerpoint/2010/main" val="2340779447"/>
+      </p:ext>
+    </p:extLst>
+  </p:cSld>
+  <p:clrMapOvr>
+    <a:masterClrMapping/>
+  </p:clrMapOvr>
+</p:sld>
+</file>
+
+<file path=ppt/slides/slide14.xml><?xml version="1.0" encoding="utf-8"?>
+<p:sld xmlns:a="http://schemas.openxmlformats.org/drawingml/2006/main" xmlns:r="http://schemas.openxmlformats.org/officeDocument/2006/relationships" xmlns:p="http://schemas.openxmlformats.org/presentationml/2006/main">
+  <p:cSld>
+    <p:spTree>
+      <p:nvGrpSpPr>
+        <p:cNvPr id="1" name=""/>
+        <p:cNvGrpSpPr/>
+        <p:nvPr/>
+      </p:nvGrpSpPr>
+      <p:grpSpPr>
+        <a:xfrm>
+          <a:off x="0" y="0"/>
+          <a:ext cx="0" cy="0"/>
+          <a:chOff x="0" y="0"/>
+          <a:chExt cx="0" cy="0"/>
+        </a:xfrm>
+      </p:grpSpPr>
+      <p:sp>
+        <p:nvSpPr>
+          <p:cNvPr id="2" name="Titel 1">
+            <a:extLst>
+              <a:ext uri="{FF2B5EF4-FFF2-40B4-BE49-F238E27FC236}">
                 <a16:creationId xmlns:a16="http://schemas.microsoft.com/office/drawing/2014/main" id="{1F47CCA5-6703-4BA0-6EF7-4489A48817D7}"/>
               </a:ext>
             </a:extLst>
@@ -5565,7 +5696,7 @@
             <a:fld id="{7759694E-24C5-490B-A8F1-97FE52F5A3A6}" type="slidenum">
               <a:rPr lang="de-CH" smtClean="0"/>
               <a:pPr/>
-              <a:t>13</a:t>
+              <a:t>14</a:t>
             </a:fld>
             <a:endParaRPr lang="de-CH" dirty="0"/>
           </a:p>
@@ -6739,38 +6870,35 @@
             <p:ph idx="1"/>
           </p:nvPr>
         </p:nvSpPr>
-        <p:spPr/>
+        <p:spPr>
+          <a:xfrm>
+            <a:off x="838200" y="1858879"/>
+            <a:ext cx="10588690" cy="4450939"/>
+          </a:xfrm>
+        </p:spPr>
         <p:txBody>
           <a:bodyPr/>
           <a:lstStyle/>
           <a:p>
             <a:r>
               <a:rPr lang="de-CH" dirty="0"/>
-              <a:t>Zeichne Linien auf ein Canvas mit einem </a:t>
-            </a:r>
-            <a:r>
-              <a:rPr lang="de-CH" dirty="0" err="1"/>
-              <a:t>HandPose</a:t>
-            </a:r>
+              <a:t>Zeichne mit Finger-Gesten Linien / Punkte auf ein Canvas</a:t>
+            </a:r>
+          </a:p>
+          <a:p>
             <a:r>
               <a:rPr lang="de-CH" dirty="0"/>
-              <a:t> Model:</a:t>
-            </a:r>
-          </a:p>
-          <a:p>
-            <a:pPr marL="0" indent="0">
-              <a:buNone/>
-            </a:pPr>
+              <a:t>Bonus: Jeder Finger soll eine andere Farbe / Grösse darstellen</a:t>
+            </a:r>
+          </a:p>
+          <a:p>
+            <a:endParaRPr lang="de-CH" dirty="0"/>
+          </a:p>
+          <a:p>
             <a:r>
               <a:rPr lang="de-CH" dirty="0"/>
-              <a:t>Jeder Finger soll eine andere Farbe / Grösse darstellen</a:t>
-            </a:r>
-          </a:p>
-          <a:p>
-            <a:pPr marL="0" indent="0">
-              <a:buNone/>
-            </a:pPr>
-            <a:endParaRPr lang="de-CH" dirty="0"/>
+              <a:t>Zähle, wie viele Finger jemand in die Höhe hält</a:t>
+            </a:r>
           </a:p>
           <a:p>
             <a:r>
@@ -6795,7 +6923,7 @@
 </file>
 
 <file path=ppt/slides/slide9.xml><?xml version="1.0" encoding="utf-8"?>
-<p:sld xmlns:a="http://schemas.openxmlformats.org/drawingml/2006/main" xmlns:r="http://schemas.openxmlformats.org/officeDocument/2006/relationships" xmlns:p="http://schemas.openxmlformats.org/presentationml/2006/main">
+<p:sld xmlns:a="http://schemas.openxmlformats.org/drawingml/2006/main" xmlns:r="http://schemas.openxmlformats.org/officeDocument/2006/relationships" xmlns:p="http://schemas.openxmlformats.org/presentationml/2006/main" show="0">
   <p:cSld>
     <p:spTree>
       <p:nvGrpSpPr>
@@ -7698,6 +7826,27 @@
 </file>
 
 <file path=customXml/item1.xml><?xml version="1.0" encoding="utf-8"?>
+<p:properties xmlns:p="http://schemas.microsoft.com/office/2006/metadata/properties" xmlns:xsi="http://www.w3.org/2001/XMLSchema-instance" xmlns:pc="http://schemas.microsoft.com/office/infopath/2007/PartnerControls">
+  <documentManagement>
+    <MediaLengthInSeconds xmlns="1dbf6c8a-8f63-44bb-83c7-9ba9b5d4efe9" xsi:nil="true"/>
+    <lcf76f155ced4ddcb4097134ff3c332f xmlns="1dbf6c8a-8f63-44bb-83c7-9ba9b5d4efe9">
+      <Terms xmlns="http://schemas.microsoft.com/office/infopath/2007/PartnerControls"/>
+    </lcf76f155ced4ddcb4097134ff3c332f>
+    <TaxCatchAll xmlns="06172d57-5d51-4d29-806c-4b74cd929571" xsi:nil="true"/>
+  </documentManagement>
+</p:properties>
+</file>
+
+<file path=customXml/item2.xml><?xml version="1.0" encoding="utf-8"?>
+<?mso-contentType ?>
+<FormTemplates xmlns="http://schemas.microsoft.com/sharepoint/v3/contenttype/forms">
+  <Display>DocumentLibraryForm</Display>
+  <Edit>DocumentLibraryForm</Edit>
+  <New>DocumentLibraryForm</New>
+</FormTemplates>
+</file>
+
+<file path=customXml/item3.xml><?xml version="1.0" encoding="utf-8"?>
 <ct:contentTypeSchema xmlns:ct="http://schemas.microsoft.com/office/2006/metadata/contentType" xmlns:ma="http://schemas.microsoft.com/office/2006/metadata/properties/metaAttributes" ct:_="" ma:_="" ma:contentTypeName="Document" ma:contentTypeID="0x0101001CD6A808F5B18B4EAF5BA513ACEC1F15" ma:contentTypeVersion="14" ma:contentTypeDescription="Crée un document." ma:contentTypeScope="" ma:versionID="90cadc050c97ef17732eccf05f282cbe">
   <xsd:schema xmlns:xsd="http://www.w3.org/2001/XMLSchema" xmlns:xs="http://www.w3.org/2001/XMLSchema" xmlns:p="http://schemas.microsoft.com/office/2006/metadata/properties" xmlns:ns2="1dbf6c8a-8f63-44bb-83c7-9ba9b5d4efe9" xmlns:ns3="06172d57-5d51-4d29-806c-4b74cd929571" targetNamespace="http://schemas.microsoft.com/office/2006/metadata/properties" ma:root="true" ma:fieldsID="4f5492ae7e1fa14b86c16250e6d1a161" ns2:_="" ns3:_="">
     <xsd:import namespace="1dbf6c8a-8f63-44bb-83c7-9ba9b5d4efe9"/>
@@ -7926,28 +8075,26 @@
 </ct:contentTypeSchema>
 </file>
 
-<file path=customXml/item2.xml><?xml version="1.0" encoding="utf-8"?>
-<?mso-contentType ?>
-<FormTemplates xmlns="http://schemas.microsoft.com/sharepoint/v3/contenttype/forms">
-  <Display>DocumentLibraryForm</Display>
-  <Edit>DocumentLibraryForm</Edit>
-  <New>DocumentLibraryForm</New>
-</FormTemplates>
+<file path=customXml/itemProps1.xml><?xml version="1.0" encoding="utf-8"?>
+<ds:datastoreItem xmlns:ds="http://schemas.openxmlformats.org/officeDocument/2006/customXml" ds:itemID="{C75C5BEF-A826-4D32-BB75-8169F3E7AF17}">
+  <ds:schemaRefs>
+    <ds:schemaRef ds:uri="http://schemas.microsoft.com/office/2006/metadata/properties"/>
+    <ds:schemaRef ds:uri="http://schemas.microsoft.com/office/infopath/2007/PartnerControls"/>
+    <ds:schemaRef ds:uri="1dbf6c8a-8f63-44bb-83c7-9ba9b5d4efe9"/>
+    <ds:schemaRef ds:uri="06172d57-5d51-4d29-806c-4b74cd929571"/>
+  </ds:schemaRefs>
+</ds:datastoreItem>
 </file>
 
-<file path=customXml/item3.xml><?xml version="1.0" encoding="utf-8"?>
-<p:properties xmlns:p="http://schemas.microsoft.com/office/2006/metadata/properties" xmlns:xsi="http://www.w3.org/2001/XMLSchema-instance" xmlns:pc="http://schemas.microsoft.com/office/infopath/2007/PartnerControls">
-  <documentManagement>
-    <MediaLengthInSeconds xmlns="1dbf6c8a-8f63-44bb-83c7-9ba9b5d4efe9" xsi:nil="true"/>
-    <lcf76f155ced4ddcb4097134ff3c332f xmlns="1dbf6c8a-8f63-44bb-83c7-9ba9b5d4efe9">
-      <Terms xmlns="http://schemas.microsoft.com/office/infopath/2007/PartnerControls"/>
-    </lcf76f155ced4ddcb4097134ff3c332f>
-    <TaxCatchAll xmlns="06172d57-5d51-4d29-806c-4b74cd929571" xsi:nil="true"/>
-  </documentManagement>
-</p:properties>
+<file path=customXml/itemProps2.xml><?xml version="1.0" encoding="utf-8"?>
+<ds:datastoreItem xmlns:ds="http://schemas.openxmlformats.org/officeDocument/2006/customXml" ds:itemID="{1AE3F8FF-813C-4132-BE80-C573B634B911}">
+  <ds:schemaRefs>
+    <ds:schemaRef ds:uri="http://schemas.microsoft.com/sharepoint/v3/contenttype/forms"/>
+  </ds:schemaRefs>
+</ds:datastoreItem>
 </file>
 
-<file path=customXml/itemProps1.xml><?xml version="1.0" encoding="utf-8"?>
+<file path=customXml/itemProps3.xml><?xml version="1.0" encoding="utf-8"?>
 <ds:datastoreItem xmlns:ds="http://schemas.openxmlformats.org/officeDocument/2006/customXml" ds:itemID="{6DE9BA2F-C062-493E-910C-72A955AF13B0}">
   <ds:schemaRefs>
     <ds:schemaRef ds:uri="http://schemas.microsoft.com/office/2006/metadata/contentType"/>
@@ -7964,23 +8111,4 @@
     <ds:schemaRef ds:uri="http://schemas.microsoft.com/internal/obd"/>
   </ds:schemaRefs>
 </ds:datastoreItem>
-</file>
-
-<file path=customXml/itemProps2.xml><?xml version="1.0" encoding="utf-8"?>
-<ds:datastoreItem xmlns:ds="http://schemas.openxmlformats.org/officeDocument/2006/customXml" ds:itemID="{1AE3F8FF-813C-4132-BE80-C573B634B911}">
-  <ds:schemaRefs>
-    <ds:schemaRef ds:uri="http://schemas.microsoft.com/sharepoint/v3/contenttype/forms"/>
-  </ds:schemaRefs>
-</ds:datastoreItem>
-</file>
-
-<file path=customXml/itemProps3.xml><?xml version="1.0" encoding="utf-8"?>
-<ds:datastoreItem xmlns:ds="http://schemas.openxmlformats.org/officeDocument/2006/customXml" ds:itemID="{C75C5BEF-A826-4D32-BB75-8169F3E7AF17}">
-  <ds:schemaRefs>
-    <ds:schemaRef ds:uri="http://schemas.microsoft.com/office/2006/metadata/properties"/>
-    <ds:schemaRef ds:uri="http://schemas.microsoft.com/office/infopath/2007/PartnerControls"/>
-    <ds:schemaRef ds:uri="1dbf6c8a-8f63-44bb-83c7-9ba9b5d4efe9"/>
-    <ds:schemaRef ds:uri="06172d57-5d51-4d29-806c-4b74cd929571"/>
-  </ds:schemaRefs>
-</ds:datastoreItem>
 </file>
</xml_diff>